<commit_message>
Refocus the Goldwind briefing on work scenes and polish Yuzhongqing notes.
Scene pages now state when a task starts, what materials enter, and what people decide; speaker notes stay customer-visible.
</commit_message>
<xml_diff>
--- a/goldwind/docs/标准知识进入工作场景.pptx
+++ b/goldwind/docs/标准知识进入工作场景.pptx
@@ -341,43 +341,31 @@
           <a:p>
             <a:r>
               <a:rPr lang="zh-CN" altLang="en-US" dirty="0"/>
-              <a:t>三个场景共用下列引用规则。知识向任务提供当前有效条款，发布与审批留在现有流程，不另设一套流程平台。</a:t>
+              <a:t>三个工作场景说明标准如何进入任务现场。检索单位是已发布的当前有效条款，须写明标准号、条款号、版本和适用范围。</a:t>
             </a:r>
           </a:p>
           <a:p>
             <a:r>
               <a:rPr lang="zh-CN" altLang="en-US" dirty="0"/>
-              <a:t>检索单位是一条当前有效条款，不是一篇标准全文，也不是一次对话的摘要。每条写明标准号、条款号、版本、适用范围。缺任何一项，该条不进入任务引用。适用范围需能区分机型或部件、市场或认证体系、供应商品类、作业类型。没有适用范围时，同一标准号会在不同任务中被误用。</a:t>
+              <a:t>认证应答：新机型、新市场或标准换版取证时，按认证体系列出条款、证据索引和偏离草稿。技术、商务、法务确认后，由授权人提交。投标侧编制方式公开材料未记载，标为待核。</a:t>
             </a:r>
           </a:p>
           <a:p>
             <a:r>
               <a:rPr lang="zh-CN" altLang="en-US" dirty="0"/>
-              <a:t>原件归档。标准文本、检测报告、合同准则等原件保存，供核对。原件不直接作为引用依据。未命中时，不改用原件起始段或相邻段落。需要查看原文时，由条款回链到原件的相应位置。</a:t>
+              <a:t>准入证据：新供应商准入、年度复审或品类扩展时，核验证书有效期、适用范围与条款命中，形成证据包。准入结论由采购与质量作出。</a:t>
             </a:r>
           </a:p>
           <a:p>
             <a:r>
               <a:rPr lang="zh-CN" altLang="en-US" dirty="0"/>
-              <a:t>先出草稿。系统可以起草应答、偏离说明或修订建议。草稿在发布前不进入检索。发布由责任人完成。未经发布的内容，包括模型当场生成的句子，不作为依据。</a:t>
+              <a:t>作业同步：标准换版后，列出可能受影响的手册、巡检项与课程，并出修订草稿。签核后发布仍走现有手册、培训、巡检流程。公开材料对对应关系记载较少，放在试点之后。</a:t>
             </a:r>
           </a:p>
           <a:p>
             <a:r>
               <a:rPr lang="zh-CN" altLang="en-US" dirty="0"/>
-              <a:t>发布与退役。只有已发布条款可以被新任务引用。修订时发布新版本并退役旧版本，不覆盖旧文。旧版本留档，供追溯当时的认证、合同和手册，不再被新任务引用。更换模型或重建索引时，只重算索引，不改写已发布正文。</a:t>
-            </a:r>
-          </a:p>
-          <a:p>
-            <a:r>
-              <a:rPr lang="zh-CN" altLang="en-US" dirty="0"/>
-              <a:t>未命中。未匹配到已发布条款，或匹配程度未达到可用条件时，结果为未覆盖。此时不改用原文起始段，不改用相邻条文，也不生成无出处的依据。未覆盖显式返回后，由责任人决定补充标准、缩小范围或停止引用。发布前可用检索预览核验将召回哪一条。预览不是发布。</a:t>
-            </a:r>
-          </a:p>
-          <a:p>
-            <a:r>
-              <a:rPr lang="zh-CN" altLang="en-US" dirty="0"/>
-              <a:t>可核对的条件是：每条被引用的内容能回到标准号、条款号、版本和原件；草稿未进入检索；退役版本不被新任务召回；未命中返回未覆盖。本材料不设定准确率百分比。</a:t>
+              <a:t>三个场景共用四项字段。已有标准系统则接入。次序为认证应答先行对照，准入其次，作业同步置后。</a:t>
             </a:r>
           </a:p>
         </p:txBody>
@@ -424,37 +412,31 @@
           <a:p>
             <a:r>
               <a:rPr lang="zh-CN" altLang="en-US" dirty="0"/>
-              <a:t>认证应答中，系统按认证体系列出条款、证据索引和偏离草稿。技术、商务、法务分别确认本段。授权人完成提交。投标文件的编制方式，公开材料未记载，标为待核。</a:t>
+              <a:t>认证符合性应答在新机型、新市场或标准换版取证时发生。路径是标准进入测试大纲，测试形成报告，报告支撑证书。</a:t>
             </a:r>
           </a:p>
           <a:p>
             <a:r>
               <a:rPr lang="zh-CN" altLang="en-US" dirty="0"/>
-              <a:t>认证侧的路径是标准、测试大纲、报告、证书。T/CEEIA 804-2024 发布后，中国电科院依据该标准对 GW155-4.5MW 做硬件在环测试，形成国内首份依标报告。标准在这里同时是测试方法和市场准入依据。2026 年上半年证书 92 张，国内 38 张、国际 54 张，覆盖多平台多机型，属于持续发生的工作。国际合格评定另有 IECRE 规则，同一机型可能准备两套材料。国家标准验证点表明检测与标准相连。</a:t>
+              <a:t>公开案例：团体标准 T/CEEIA 804-2024 发布后，GW155-4.5MW 经中国电科院检测，取得国内首份依标硬件在环报告。2026 年上半年获认证证书 92 张，国内 38 张、国际 54 张，覆盖多平台多机型。同一机型常同时面对国内与国际两套规则。</a:t>
             </a:r>
           </a:p>
           <a:p>
             <a:r>
               <a:rPr lang="zh-CN" altLang="en-US" dirty="0"/>
-              <a:t>系统产出三项。条款清单：按该认证体系列出应引用的当前有效条款，带标准号、条款号、版本、适用范围。证据索引：每条指向已有报告、大纲或原件；没有证据时标为未覆盖，不编造报告编号。偏离草稿：列出待确认的偏离点。未达到匹配条件的条目保持未覆盖，不补写为符合。</a:t>
+              <a:t>系统按认证体系列出应引用的当前有效条款，带标准号、条款号、版本、适用范围；每条指向已有报告、大纲或原件；没有证据标为未覆盖。偏离草稿列出待确认点。系统不代替检测报告和证书。</a:t>
             </a:r>
           </a:p>
           <a:p>
             <a:r>
               <a:rPr lang="zh-CN" altLang="en-US" dirty="0"/>
-              <a:t>技术岗位确认偏离在工程上是否成立，商务岗位确认是否涉及交付和商务条件，法务岗位确认是否涉及义务表述。三方各自确认本段。意见齐备后，由授权人决定能否提交。系统不替代检测报告和证书，不签字，不盖章。</a:t>
+              <a:t>技术确认偏离在工程上是否成立，商务确认是否涉及交付条件，法务确认是否涉及义务表述。意见齐备后，由授权人决定能否提交。签字、盖章与对外提交由授权人完成。</a:t>
             </a:r>
           </a:p>
           <a:p>
             <a:r>
               <a:rPr lang="zh-CN" altLang="en-US" dirty="0"/>
-              <a:t>投标侧标为待核。公开信息可以确认天工招采是电子招投标平台。技术偏离表、符合性声明的编写岗位、模板，以及与认证材料是否复用，公开材料未记载。后续若提供历史标书，可另作对照。本次范围不含投标文件的自动编制。认证侧先行，是因为证书、报告和验证点已有公开材料。</a:t>
-            </a:r>
-          </a:p>
-          <a:p>
-            <a:r>
-              <a:rPr lang="zh-CN" altLang="en-US" dirty="0"/>
-              <a:t>对照方式：选定一个真实认证包，系统出具清单和草稿，正式稿仍按现行岗位编制。两边对照引用能否回链、未命中是否标为未覆盖、偏离是否标为待确认。正式提交仍走原路径，不写入招采平台或认证档案系统。对照不约定工时。</a:t>
+              <a:t>投标侧：天工招采可确认存在。技术偏离表与符合性声明的编制方式公开材料未记载，标为待核。本次范围以认证侧为主，不把投标全流程写入承诺。</a:t>
             </a:r>
           </a:p>
         </p:txBody>
@@ -501,37 +483,25 @@
           <a:p>
             <a:r>
               <a:rPr lang="zh-CN" altLang="en-US" dirty="0"/>
-              <a:t>供应商准入中，系统核验证书有效期、适用范围和条款命中。是否准入由采购与质量作出。证据规则明确，产出是证据包和待补项。结论与质量责任相连，通过状态由授权岗位给出。</a:t>
+              <a:t>供应商准入证据包在新供应商准入、年度复审或品类扩展时发生。公开流程包括开发、资料审核、考察、认证评分、产品试制、小批量验证、产品认证评分。</a:t>
             </a:r>
           </a:p>
           <a:p>
             <a:r>
               <a:rPr lang="zh-CN" altLang="en-US" dirty="0"/>
-              <a:t>公开流程包括开发、资料审核、考察、认证评分、产品试制、小批量验证、产品认证评分。标准以品类关联规则进入采购平台，社会责任准则进入框架合同并要求承诺书，绿色评价采用现场审核与文件审核，对象包括叶片、发电机、轴承、铸件、塔架。单家供应商的材料因此跨越证书、品类标准、合同准则和评价表。需要单独标出的两类差异是证书过期，以及认证范围与所供品类不符。这两类差异关系质量与合规责任。</a:t>
+              <a:t>标准以品类关联规则进入采购平台。社会责任准则进入框架合同并要求承诺书。绿色评价采用现场与文件审核，对象包括叶片、发电机、轴承、铸件、塔架。</a:t>
             </a:r>
           </a:p>
           <a:p>
             <a:r>
               <a:rPr lang="zh-CN" altLang="en-US" dirty="0"/>
-              <a:t>系统产出包括三项。有效期：标出证书是否在有效期内。适用范围：标出认证范围是否覆盖本次品类。条款命中：标出准则或评价规范中的要求，在提交材料中是否有对应证据。缺证、超范围、过期标为待补，不改为通过。系统不修改框架合同，不生成评分。一条相似描述只作为候选，不表示规则已经全部满足。</a:t>
+              <a:t>系统核验证书是否在有效期内、认证范围是否覆盖本次品类、准则或评价规范中的要求是否有对应证据。缺证、超范围、过期标为待补。系统不修改框架合同，不生成评分，不写出准入通过。</a:t>
             </a:r>
           </a:p>
           <a:p>
             <a:r>
               <a:rPr lang="zh-CN" altLang="en-US" dirty="0"/>
-              <a:t>采购确认商务条件与准入流程是否继续，质量确认技术与质量证据是否支持。观察、补件、不通过由授权岗位选择。系统不替代准入结论。</a:t>
-            </a:r>
-          </a:p>
-          <a:p>
-            <a:r>
-              <a:rPr lang="zh-CN" altLang="en-US" dirty="0"/>
-              <a:t>证书今天由人工核对还是已有平台字段、品类规则写在供应商平台的哪一层、绿色评价的检查表是否已经结构化，公开材料未记载，标为待核。后续可用脱敏后的准入档案做对照。本次不约定档案份数和工时，也不做效率测算。</a:t>
-            </a:r>
-          </a:p>
-          <a:p>
-            <a:r>
-              <a:rPr lang="zh-CN" altLang="en-US" dirty="0"/>
-              <a:t>认证应答面向机型与市场，准入面向供应商材料。两者都使用标准号、条款号、版本、适用范围。准入另有一条规则：过期和范围不符的结果为待补，不进入通过状态。</a:t>
+              <a:t>采购确认商务条件与流程是否继续，质量确认技术与质量证据是否支持。观察、补件、不通过由授权岗位选择。过期和范围不符不得进入通过状态。</a:t>
             </a:r>
           </a:p>
         </p:txBody>
@@ -578,37 +548,25 @@
           <a:p>
             <a:r>
               <a:rPr lang="zh-CN" altLang="en-US" dirty="0"/>
-              <a:t>作业同步处理标准换版之后，手册、巡检项和课程如何修订。公开材料少于认证和准入，因此排在这两个场景之后。</a:t>
+              <a:t>作业同步在标准换版或新增后发生。载体包括技术手册、巡检项、告警工单与培训课程。手册系统、304 门课程、标准化巡检均有公开记载。</a:t>
             </a:r>
           </a:p>
           <a:p>
             <a:r>
               <a:rPr lang="zh-CN" altLang="en-US" dirty="0"/>
-              <a:t>载体已经存在。手册系统覆盖安装、调试、运行、维护，并支持一次生成、多次使用。巡检覆盖风机、光伏、集电线路、升压站，系统可生成告警工单。培训有 304 门课程、253 名内训师和金风大学。公开材料未记载哪一条手册、哪一道题目、哪一个巡检判据来自哪一版标准的哪一条，也未记载改版后的更新机制。培训平台的公开转载缺少稳定出处。课程规模以企业正式披露为准，课程与条款的对应标为待核。</a:t>
+              <a:t>公开材料未记载手册条目、课程、巡检判据与标准号、条款号、版本的对应，也未记载更新机制，故标为待核，并放在认证与准入之后开展。</a:t>
             </a:r>
           </a:p>
           <a:p>
             <a:r>
               <a:rPr lang="zh-CN" altLang="en-US" dirty="0"/>
-              <a:t>对应关系核对之后，系统做两件事。影响清单：一次换版列出可能受影响的手册、巡检项和课程，清单是候选，不是已经生效的修改。修订草稿：按新条款给出修改建议。对应关系未核对时，清单标为待核，不作为完整影响面。</a:t>
+              <a:t>对应关系核对后，系统列出可能受影响的手册、巡检项与课程，并按新条款给出修订草稿。清单是候选，不是已经生效的修改。对应关系未核时，清单保持待核。</a:t>
             </a:r>
           </a:p>
           <a:p>
             <a:r>
               <a:rPr lang="zh-CN" altLang="en-US" dirty="0"/>
-              <a:t>工程负责人确认手册及与设计相关的内容，运维负责人确认巡检和现场作业，培训负责人确认课程和题库。签核之后，发布仍走现有手册、培训和巡检流程。系统不改变发布流程，不向场站自动下发，不替代签核。告警工单仍是待办，作业许可由现场负责人作出。</a:t>
-            </a:r>
-          </a:p>
-          <a:p>
-            <a:r>
-              <a:rPr lang="zh-CN" altLang="en-US" dirty="0"/>
-              <a:t>该场景涉及手册、培训、巡检三处载体，依赖尚未公开的对应关系。作业链又没有证书和合同那种外部核对。条款引用以及认证、准入两个场景先建立可回链的依据，再决定是否做载体同步。一次换版目前由谁通知谁，公开材料未记载，标为待核。若已有通知单或改版台账，接入该单据，发布仍走原流程。</a:t>
-            </a:r>
-          </a:p>
-          <a:p>
-            <a:r>
-              <a:rPr lang="zh-CN" altLang="en-US" dirty="0"/>
-              <a:t>运营知识平台中的故障诊断和监盘策略，依据的是运行数据与处置策略。本场景同步的是标准条款到作业文件的版本。两类内容分别管理。</a:t>
+              <a:t>工程确认手册及相关内容，运维确认巡检与现场作业，培训确认课程与题库。签核之后，发布仍走现有手册、培训、巡检流程。系统不向场站自动下发。告警工单仍是待办，作业许可由现场负责人作出。</a:t>
             </a:r>
           </a:p>
         </p:txBody>
@@ -655,37 +613,25 @@
           <a:p>
             <a:r>
               <a:rPr lang="zh-CN" altLang="en-US" dirty="0"/>
-              <a:t>三个场景共用同一套最小结构。没有标准、机型与市场的对应，认证应答无法定位条款。没有品类与准则的对应，准入无法核对证据。没有标准与载体的对应，换版无法列出手册、巡检和课程。该结构向任务提供可引用条款，不另设治理平台。</a:t>
+              <a:t>三个场景共用同一套最小前提，不单独立项建设文档库。已有标准系统并能提供四项字段时接入；没有则为选定场景做最小集。</a:t>
             </a:r>
           </a:p>
           <a:p>
             <a:r>
               <a:rPr lang="zh-CN" altLang="en-US" dirty="0"/>
-              <a:t>四项字段为标准号、条款号、版本、适用范围，缺一则不进入引用。文件级保存只能说明标准文本在库，不能回答这一任务使用哪一条、哪一版。适用范围至少区分机型或部件、市场或认证体系、供应商品类、作业类型。企业标准若有内部编号，与外部标准的采标关系写入适用范围或对应表。缺少这层时，内部红线无法被检索到。</a:t>
+              <a:t>四项字段：标准号、条款号、版本、适用范围。缺一则不进入任务引用。</a:t>
             </a:r>
           </a:p>
           <a:p>
             <a:r>
               <a:rPr lang="zh-CN" altLang="en-US" dirty="0"/>
-              <a:t>三张对应。第一张是标准、机型与市场：哪一型号在哪一市场、哪一认证体系下引用哪些条款。2026 年上半年 92 张证书覆盖多平台多机型，全表规模大。试点只做选定机型和选定市场。第二张是标准到载体：手册、合同准则、巡检项、课程。作业同步依赖这张表，公开材料未记载，标为待核。第三张是版本替代：新版本发布，旧版本退役并留档，新任务只引用未退役的已发布版本。</a:t>
+              <a:t>机型与市场对应支撑认证应答定位条款。载体对应支撑作业同步。版本替代保证新任务只引用未退役的已发布版本。</a:t>
             </a:r>
           </a:p>
           <a:p>
             <a:r>
               <a:rPr lang="zh-CN" altLang="en-US" dirty="0"/>
-              <a:t>是否已有标准管理系统或台账、归口岗位、发布和退役的签批岗位、检索按文件还是按条款，公开材料未记载，标为待核。已有系统并能提供四项字段时，接入该系统，原有审批保留。没有时，为试点场景建立最小可用集，不先把 699 项全部结构化。</a:t>
-            </a:r>
-          </a:p>
-          <a:p>
-            <a:r>
-              <a:rPr lang="zh-CN" altLang="en-US" dirty="0"/>
-              <a:t>原件、已发布条款、检索索引分开存放。原件用于核对，已发布条款用于引用，索引用于查找。重建索引或更换模型时，不改写已发布正文。模型升级不改变已经被认证或合同引用过的条文。</a:t>
-            </a:r>
-          </a:p>
-          <a:p>
-            <a:r>
-              <a:rPr lang="zh-CN" altLang="en-US" dirty="0"/>
-              <a:t>底座向任务提供可引用条款。认证档案、准入结论、手册发布、课程发布仍留在原系统。发布由标准化归口签批。场景是否使用这四项字段，由业务责任岗位确定。</a:t>
+              <a:t>公开材料未证明这三张对应均已存在，标为待核。试点只覆盖选定机型、品类或手册范围，不追求全量 699 项结构化。</a:t>
             </a:r>
           </a:p>
         </p:txBody>
@@ -732,43 +678,37 @@
           <a:p>
             <a:r>
               <a:rPr lang="zh-CN" altLang="en-US" dirty="0"/>
-              <a:t>本页是试点次序，不约定周期，也不约定人天。次序随待核项的核对结果确定。本次不承诺周期和效果。</a:t>
+              <a:t>次序服务三个工作场景，不约定周期与人天。</a:t>
             </a:r>
           </a:p>
           <a:p>
             <a:r>
               <a:rPr lang="zh-CN" altLang="en-US" dirty="0"/>
-              <a:t>第一步，核对现有标准系统：是否已有统一的标准库或台账，发布和退役的现行流程，检索能否回到条款。已有则接入，没有则只为选定场景做最小集。是否已用模型做标准问答或文档生成，公开材料未记载，标为待核。已有该能力则接入，避免平行再建一套。</a:t>
+              <a:t>先确认是否已有标准系统、发布流程与条款级检索。已有则接入，没有则为选定场景做最小集。</a:t>
             </a:r>
           </a:p>
           <a:p>
             <a:r>
               <a:rPr lang="zh-CN" altLang="en-US" dirty="0"/>
-              <a:t>第二步，核对三张对应：机型与市场、载体、版本替代。缺哪一张，先补该张在选定范围内的最小部分。认证应答至少具备选定机型的标准与市场对应。准入至少具备选定品类的准则对应。作业同步至少具备选定手册或课程的载体对应。三张对应都未形成之前，三个场景不并行铺开。</a:t>
+              <a:t>认证应答先行对照：选定真实认证包，系统出条款清单、证据索引与偏离草稿，正式提交仍由授权人完成。</a:t>
             </a:r>
           </a:p>
           <a:p>
             <a:r>
               <a:rPr lang="zh-CN" altLang="en-US" dirty="0"/>
-              <a:t>第三步，核对两条现行办法。投标侧：偏离表和符合性声明的编写岗位、模板，以及与认证材料是否复用。准入侧：证书有效期和范围的现行核对方式，以及有权给出准入结论的岗位。这两项决定投标侧是否纳入范围，以及准入证据包由哪一岗位确认。责任岗位以企业内部职责为准。</a:t>
+              <a:t>准入证据包其次：规则明确，但通过状态关系质量责任，须先把过期或超范围标为待补、结论由人作出写成规则。</a:t>
             </a:r>
           </a:p>
           <a:p>
             <a:r>
               <a:rPr lang="zh-CN" altLang="en-US" dirty="0"/>
-              <a:t>第四步，认证应答做对照。选定一个真实认证包，系统出具条款清单、证据索引和偏离草稿，正式编制仍由原岗位完成。对照引用能否回链、未命中是否标为未覆盖、偏离是否标为待确认。对照完成前不自动提交，也不替换现行认证流程。</a:t>
+              <a:t>作业同步置后：依赖载体对应，且涉及手册、培训、巡检三处发布；公开证据较弱。</a:t>
             </a:r>
           </a:p>
           <a:p>
             <a:r>
               <a:rPr lang="zh-CN" altLang="en-US" dirty="0"/>
-              <a:t>第五步，次序。准入证据包放在认证对照之后：规则明确，同时通过状态关系质量责任，需先把「过期或超范围则为待补」写成产品规则。作业同步放在最后：它依赖载体对应，并涉及手册、培训、巡检三处发布流程。岗位问答若后续开展，范围限于已发布条款的检索，专家评审仍由专家完成。</a:t>
-            </a:r>
-          </a:p>
-          <a:p>
-            <a:r>
-              <a:rPr lang="zh-CN" altLang="en-US" dirty="0"/>
-              <a:t>可复核的条件是：引用带有标准号、条款号、版本和原件；草稿未进入检索；退役版本不被新任务引用；未命中返回未覆盖；准入中过期或超范围不会变成通过。认证周期、不符合项、重复试验若企业已有内部基线，可在以后作为观察项。本次不引用、不估算这些数字。</a:t>
+              <a:t>可复核条件：引用带回标准号、条款号、版本与原件；草稿未进入检索；未命中返回未覆盖；准入过期或超范围不进入通过。</a:t>
             </a:r>
           </a:p>
         </p:txBody>
@@ -815,31 +755,19 @@
           <a:p>
             <a:r>
               <a:rPr lang="zh-CN" altLang="en-US" dirty="0"/>
-              <a:t>本期可做四件事：按条款检索当前有效依据；将任务材料与条款比对并标出偏离；输出应答或修订草稿；未命中则返回未覆盖。产出停在检索和草稿。检索预览用于发布前核验将召回哪一条，预览不是发布。</a:t>
+              <a:t>本期可做限于三个工作场景的检索与草稿：认证应答的条款清单与偏离草稿，准入的证据包与待补项，作业同步的影响清单与修订草稿。未命中返回未覆盖。</a:t>
             </a:r>
           </a:p>
           <a:p>
             <a:r>
               <a:rPr lang="zh-CN" altLang="en-US" dirty="0"/>
-              <a:t>仍由授权岗位完成的事项：定结论、签字、放行、对外。其中包括认证签署与盖章、供应商准入结论、设计红线符合性、安全作业许可、报价与法律终稿、对外口径。</a:t>
+              <a:t>仍由授权岗位完成：定结论、签字、放行、对外。包括认证签署与盖章、供应商准入结论、设计红线符合性、安全作业许可、报价与法律终稿、对外口径。</a:t>
             </a:r>
           </a:p>
           <a:p>
             <a:r>
               <a:rPr lang="zh-CN" altLang="en-US" dirty="0"/>
-              <a:t>本次交流不构成签约，也不构成效果承诺。材料不引用厂商或企业自报的效率、准确率、覆盖率。公开材料未记载的事项保持待核，包括标准系统是否已有、机型与市场的对应、换版通知、投标编制方式、课程与条款的对应、企业标准清单、是否已有标准问答。已有系统则接入。草稿不写入现有业务系统。</a:t>
-            </a:r>
-          </a:p>
-          <a:p>
-            <a:r>
-              <a:rPr lang="zh-CN" altLang="en-US" dirty="0"/>
-              <a:t>后续可核对的事项包括：现有标准系统与发布流程，一个可脱敏认证包所依据的条款路径，准入证据的现行核对方式。作业同步、投标文件的全量编制、效益测算不在本次范围。</a:t>
-            </a:r>
-          </a:p>
-          <a:p>
-            <a:r>
-              <a:rPr lang="zh-CN" altLang="en-US" dirty="0"/>
-              <a:t>本次交流的口径：标准参与存量以 2026 年 6 月 30 日公开数字为准；作业链与条款是否同步，标为待核；系统做到找依据、做比对、出草稿、标风险；定结论、签字、放行、对外由授权岗位完成；本次交流不构成签约或效果承诺。</a:t>
+              <a:t>本次交流不构成签约或效果承诺。不引用自报效率。公开未记载事项保持待核。已有标准系统则接入。草稿不写入现有业务系统。</a:t>
             </a:r>
           </a:p>
         </p:txBody>
@@ -886,37 +814,25 @@
           <a:p>
             <a:r>
               <a:rPr lang="zh-CN" altLang="en-US" dirty="0"/>
-              <a:t>材料分四部分。</a:t>
+              <a:t>材料分四部分。前两段确认标准已在册、已进入工作，并标出待核断点。</a:t>
             </a:r>
           </a:p>
           <a:p>
             <a:r>
               <a:rPr lang="zh-CN" altLang="en-US" dirty="0"/>
-              <a:t>客户理解（第 4 至 6 页）说明三项公开事实：标准参与已有可核对的存量；标准已进入设计、认证、供应与作业；行业实践中，文档可进入助手，放行与签字由责任人完成。</a:t>
+              <a:t>第三部分是重点：三个工作场景说明标准在任务发生时如何被引用。场景总览之后分别展开认证应答、准入证据、作业同步。</a:t>
             </a:r>
           </a:p>
           <a:p>
             <a:r>
               <a:rPr lang="zh-CN" altLang="en-US" dirty="0"/>
-              <a:t>三处断点（第 7 至 9 页）列出待核事项：换版影响面、任务中的条款定位、手册课程巡检与条款是否同步。随后列出仍由授权岗位完成的决定，包括签署、准入结论、设计符合性、安全许可和对外口径。</a:t>
+              <a:t>第四部分说明三个场景共用的前提，以及先对照哪个场景。底座服务场景，不单独立项。</a:t>
             </a:r>
           </a:p>
           <a:p>
             <a:r>
               <a:rPr lang="zh-CN" altLang="en-US" dirty="0"/>
-              <a:t>工作场景（第 10 至 13 页）先规定条款如何被引用，再列三个场景。认证侧有证书、报告可核对，先行；投标文件的编制方式公开材料未记载，标为待核。准入场景核验证书有效期、适用范围与条款命中，准入结论由采购与质量作出。作业同步的公开材料较少，排在两个场景之后。</a:t>
-            </a:r>
-          </a:p>
-          <a:p>
-            <a:r>
-              <a:rPr lang="zh-CN" altLang="en-US" dirty="0"/>
-              <a:t>落地边界（第 14 至 16 页）说明共用的四项字段和三张对应。已有标准系统则接入，没有则按选定场景做最小可用集。所列顺序是试点次序。本次交流不构成签约或效果承诺。</a:t>
-            </a:r>
-          </a:p>
-          <a:p>
-            <a:r>
-              <a:rPr lang="zh-CN" altLang="en-US" dirty="0"/>
-              <a:t>若企业内部已有标准管理系统，后续按接入处理。需核对的事项包括系统名称、覆盖范围、检索单位是否为条款，以及发布与退役的责任岗位。签署、准入、放行和对外口径仍由授权岗位完成。</a:t>
+              <a:t>已有标准系统则接入。签署、准入结论、放行与对外口径仍由授权岗位完成。</a:t>
             </a:r>
           </a:p>
         </p:txBody>
@@ -1425,49 +1341,43 @@
           <a:p>
             <a:r>
               <a:rPr lang="zh-CN" altLang="en-US" dirty="0"/>
-              <a:t>下列决定由企业授权岗位完成。系统的产出停在依据、比对、草稿和风险提示。</a:t>
+              <a:t>下列决定由企业授权岗位完成。系统产出停在依据、比对、草稿和风险提示。三个工作场景均遵守本页边界。</a:t>
             </a:r>
           </a:p>
           <a:p>
             <a:r>
               <a:rPr lang="zh-CN" altLang="en-US" dirty="0"/>
-              <a:t>认证签署。证书、检测报告和投标文件的签字盖章由授权人完成。原始记录保持可追溯，报告追溯到方法、设备和校准。中国电科院出具的依标报告，出证主体是检测机构。系统列出条款、证据索引和偏离草稿，提交由授权人执行。</a:t>
+              <a:t>认证签署。证书、检测报告和投标文件的签字盖章由授权人完成。系统列出条款、证据索引和偏离草稿，提交由授权人执行。</a:t>
             </a:r>
           </a:p>
           <a:p>
             <a:r>
               <a:rPr lang="zh-CN" altLang="en-US" dirty="0"/>
-              <a:t>准入结论。证书过期或认证范围与所供品类不符时，结果为待补，不进入通过。检索到一条相似条款，只说明有候选依据，并不表示该品类的全部规则已经满足。通过、观察或不通过由采购与质量作出。系统输出证据是否齐、哪一项超范围或过期。</a:t>
+              <a:t>准入结论。证书过期或认证范围与所供品类不符时，结果为待补，不进入通过。通过、观察或不通过由采购与质量作出。</a:t>
             </a:r>
           </a:p>
           <a:p>
             <a:r>
               <a:rPr lang="zh-CN" altLang="en-US" dirty="0"/>
-              <a:t>设计符合。核心部件设计红线是否满足，由设计确认。换版之后，原有符合性判断不自动沿用，需能看到版本差异。系统并列显示红线条款与设计输入的差异，结论留在设计评审。</a:t>
+              <a:t>设计符合。核心部件设计红线是否满足，由设计确认。系统并列显示红线条款与设计输入的差异。</a:t>
             </a:r>
           </a:p>
           <a:p>
             <a:r>
               <a:rPr lang="zh-CN" altLang="en-US" dirty="0"/>
-              <a:t>安全许可。停电、动火、高空、受限空间等作业许可由现场负责人作出。标准化巡检生成告警工单，工单是待办。系统提示依据和风险，现场措施按现有规程由责任人确认。</a:t>
+              <a:t>安全许可。停电、动火、高空、受限空间等作业许可由现场负责人作出。告警工单是待办，不是放行。</a:t>
             </a:r>
           </a:p>
           <a:p>
             <a:r>
               <a:rPr lang="zh-CN" altLang="en-US" dirty="0"/>
-              <a:t>对外口径。报价、交付承诺、法律条款的终稿，以及对外披露和可持续报告中的数字，由对应责任人定稿。系统不出对外文本。</a:t>
+              <a:t>对外口径。报价、交付承诺、法律条款终稿，以及对外披露中的数字，由对应责任人定稿。</a:t>
             </a:r>
           </a:p>
           <a:p>
             <a:r>
               <a:rPr lang="zh-CN" altLang="en-US" dirty="0"/>
-              <a:t>写回。DEEP、风匠、天工、擎风、SOAM、供应商平台、手册系统、招采平台、培训平台，各自保持现有发布和审批。本次范围不包含把草稿直接写入这些系统。写回需另备草稿、审批、回滚和审计，不在本次交流的范围内。</a:t>
-            </a:r>
-          </a:p>
-          <a:p>
-            <a:r>
-              <a:rPr lang="zh-CN" altLang="en-US" dirty="0"/>
-              <a:t>系统做到找依据、做比对、出草稿、标风险。定结论、签字、放行、对外由授权岗位完成，每类动作有唯一责任岗位。</a:t>
+              <a:t>系统做到找依据、做比对、出草稿、标风险。定结论、签字、放行、对外由授权岗位完成。</a:t>
             </a:r>
           </a:p>
         </p:txBody>
@@ -2476,7 +2386,7 @@
                 <a:latin typeface="PingFang SC"/>
                 <a:ea typeface="PingFang SC"/>
               </a:rPr>
-              <a:t>如何引用</a:t>
+              <a:t>场景总览</a:t>
             </a:r>
             <a:endParaRPr lang="zh-CN" sz="2400" b="1" spc="-37">
               <a:solidFill>
@@ -2544,7 +2454,7 @@
                 <a:latin typeface="Inter"/>
                 <a:ea typeface="Inter"/>
               </a:rPr>
-              <a:t>CITE</a:t>
+              <a:t>SCENES</a:t>
             </a:r>
             <a:endParaRPr lang="en-US" sz="975" spc="225">
               <a:solidFill>
@@ -2755,7 +2665,7 @@
                 <a:latin typeface="PingFang SC"/>
                 <a:ea typeface="PingFang SC"/>
               </a:rPr>
-              <a:t>条款单位</a:t>
+              <a:t>认证应答</a:t>
             </a:r>
             <a:endParaRPr lang="zh-CN" sz="1500" b="1" spc="-22">
               <a:solidFill>
@@ -2825,7 +2735,7 @@
                 <a:latin typeface="PingFang SC"/>
                 <a:ea typeface="PingFang SC"/>
               </a:rPr>
-              <a:t>有效条款为检索单位</a:t>
+              <a:t>新机型或新市场取证时组织证据</a:t>
             </a:r>
             <a:endParaRPr lang="zh-CN" sz="1125">
               <a:solidFill>
@@ -2893,7 +2803,7 @@
                 <a:latin typeface="PingFang SC"/>
                 <a:ea typeface="PingFang SC"/>
               </a:rPr>
-              <a:t>标准号</a:t>
+              <a:t>条款清单</a:t>
             </a:r>
             <a:endParaRPr lang="zh-CN" sz="1050">
               <a:solidFill>
@@ -2961,7 +2871,7 @@
                 <a:latin typeface="PingFang SC"/>
                 <a:ea typeface="PingFang SC"/>
               </a:rPr>
-              <a:t>条款号</a:t>
+              <a:t>偏离草稿</a:t>
             </a:r>
             <a:endParaRPr lang="zh-CN" sz="1050">
               <a:solidFill>
@@ -3029,7 +2939,7 @@
                 <a:latin typeface="PingFang SC"/>
                 <a:ea typeface="PingFang SC"/>
               </a:rPr>
-              <a:t>版本号</a:t>
+              <a:t>授权提交</a:t>
             </a:r>
             <a:endParaRPr lang="zh-CN" sz="1050">
               <a:solidFill>
@@ -3107,7 +3017,7 @@
                 <a:latin typeface="PingFang SC"/>
                 <a:ea typeface="PingFang SC"/>
               </a:rPr>
-              <a:t>适用范围</a:t>
+              <a:t>认证先行</a:t>
             </a:r>
             <a:endParaRPr lang="zh-CN" sz="900">
               <a:solidFill>
@@ -3305,7 +3215,7 @@
                 <a:latin typeface="PingFang SC"/>
                 <a:ea typeface="PingFang SC"/>
               </a:rPr>
-              <a:t>原件留档</a:t>
+              <a:t>准入证据</a:t>
             </a:r>
             <a:endParaRPr lang="zh-CN" sz="1500" b="1" spc="-22">
               <a:solidFill>
@@ -3375,7 +3285,7 @@
                 <a:latin typeface="PingFang SC"/>
                 <a:ea typeface="PingFang SC"/>
               </a:rPr>
-              <a:t>原件归档不作依据</a:t>
+              <a:t>新供应商准入时核对证书与条款</a:t>
             </a:r>
             <a:endParaRPr lang="zh-CN" sz="1125">
               <a:solidFill>
@@ -3443,7 +3353,7 @@
                 <a:latin typeface="PingFang SC"/>
                 <a:ea typeface="PingFang SC"/>
               </a:rPr>
-              <a:t>标准文本</a:t>
+              <a:t>有效期</a:t>
             </a:r>
             <a:endParaRPr lang="zh-CN" sz="1050">
               <a:solidFill>
@@ -3511,7 +3421,7 @@
                 <a:latin typeface="PingFang SC"/>
                 <a:ea typeface="PingFang SC"/>
               </a:rPr>
-              <a:t>版本留存</a:t>
+              <a:t>范围命中</a:t>
             </a:r>
             <a:endParaRPr lang="zh-CN" sz="1050">
               <a:solidFill>
@@ -3579,7 +3489,7 @@
                 <a:latin typeface="PingFang SC"/>
                 <a:ea typeface="PingFang SC"/>
               </a:rPr>
-              <a:t>不作引用</a:t>
+              <a:t>证据包</a:t>
             </a:r>
             <a:endParaRPr lang="zh-CN" sz="1050">
               <a:solidFill>
@@ -3657,7 +3567,7 @@
                 <a:latin typeface="PingFang SC"/>
                 <a:ea typeface="PingFang SC"/>
               </a:rPr>
-              <a:t>留作底稿</a:t>
+              <a:t>结论在人</a:t>
             </a:r>
             <a:endParaRPr lang="zh-CN" sz="900">
               <a:solidFill>
@@ -3855,7 +3765,7 @@
                 <a:latin typeface="PingFang SC"/>
                 <a:ea typeface="PingFang SC"/>
               </a:rPr>
-              <a:t>先出草稿</a:t>
+              <a:t>作业同步</a:t>
             </a:r>
             <a:endParaRPr lang="zh-CN" sz="1500" b="1" spc="-22">
               <a:solidFill>
@@ -3925,7 +3835,7 @@
                 <a:latin typeface="PingFang SC"/>
                 <a:ea typeface="PingFang SC"/>
               </a:rPr>
-              <a:t>发布前草稿不召回</a:t>
+              <a:t>标准换版后列出受影响载体</a:t>
             </a:r>
             <a:endParaRPr lang="zh-CN" sz="1125">
               <a:solidFill>
@@ -3993,7 +3903,7 @@
                 <a:latin typeface="PingFang SC"/>
                 <a:ea typeface="PingFang SC"/>
               </a:rPr>
-              <a:t>系统起草</a:t>
+              <a:t>影响清单</a:t>
             </a:r>
             <a:endParaRPr lang="zh-CN" sz="1050">
               <a:solidFill>
@@ -4061,7 +3971,7 @@
                 <a:latin typeface="PingFang SC"/>
                 <a:ea typeface="PingFang SC"/>
               </a:rPr>
-              <a:t>责任人核</a:t>
+              <a:t>修订草稿</a:t>
             </a:r>
             <a:endParaRPr lang="zh-CN" sz="1050">
               <a:solidFill>
@@ -4129,7 +4039,7 @@
                 <a:latin typeface="PingFang SC"/>
                 <a:ea typeface="PingFang SC"/>
               </a:rPr>
-              <a:t>待发布</a:t>
+              <a:t>原流程发</a:t>
             </a:r>
             <a:endParaRPr lang="zh-CN" sz="1050">
               <a:solidFill>
@@ -4207,7 +4117,7 @@
                 <a:latin typeface="PingFang SC"/>
                 <a:ea typeface="PingFang SC"/>
               </a:rPr>
-              <a:t>草稿隔离</a:t>
+              <a:t>试点置后</a:t>
             </a:r>
             <a:endParaRPr lang="zh-CN" sz="900">
               <a:solidFill>
@@ -4405,7 +4315,7 @@
                 <a:latin typeface="PingFang SC"/>
                 <a:ea typeface="PingFang SC"/>
               </a:rPr>
-              <a:t>发布退役</a:t>
+              <a:t>共用前提</a:t>
             </a:r>
             <a:endParaRPr lang="zh-CN" sz="1500" b="1" spc="-22">
               <a:solidFill>
@@ -4475,7 +4385,7 @@
                 <a:latin typeface="PingFang SC"/>
                 <a:ea typeface="PingFang SC"/>
               </a:rPr>
-              <a:t>发新条，旧条留档</a:t>
+              <a:t>四项字段齐全方可引用</a:t>
             </a:r>
             <a:endParaRPr lang="zh-CN" sz="1125">
               <a:solidFill>
@@ -4543,7 +4453,7 @@
                 <a:latin typeface="PingFang SC"/>
                 <a:ea typeface="PingFang SC"/>
               </a:rPr>
-              <a:t>发布新条</a:t>
+              <a:t>标准号</a:t>
             </a:r>
             <a:endParaRPr lang="zh-CN" sz="1050">
               <a:solidFill>
@@ -4611,7 +4521,7 @@
                 <a:latin typeface="PingFang SC"/>
                 <a:ea typeface="PingFang SC"/>
               </a:rPr>
-              <a:t>退役旧条</a:t>
+              <a:t>条款号</a:t>
             </a:r>
             <a:endParaRPr lang="zh-CN" sz="1050">
               <a:solidFill>
@@ -4679,7 +4589,7 @@
                 <a:latin typeface="PingFang SC"/>
                 <a:ea typeface="PingFang SC"/>
               </a:rPr>
-              <a:t>旧条留档</a:t>
+              <a:t>版本号</a:t>
             </a:r>
             <a:endParaRPr lang="zh-CN" sz="1050">
               <a:solidFill>
@@ -4757,7 +4667,7 @@
                 <a:latin typeface="PingFang SC"/>
                 <a:ea typeface="PingFang SC"/>
               </a:rPr>
-              <a:t>发布可查</a:t>
+              <a:t>适用范围</a:t>
             </a:r>
             <a:endParaRPr lang="zh-CN" sz="900">
               <a:solidFill>
@@ -4955,7 +4865,7 @@
                 <a:latin typeface="PingFang SC"/>
                 <a:ea typeface="PingFang SC"/>
               </a:rPr>
-              <a:t>未命中</a:t>
+              <a:t>场景次序</a:t>
             </a:r>
             <a:endParaRPr lang="zh-CN" sz="1500" b="1" spc="-22">
               <a:solidFill>
@@ -5025,7 +4935,7 @@
                 <a:latin typeface="PingFang SC"/>
                 <a:ea typeface="PingFang SC"/>
               </a:rPr>
-              <a:t>未达条件即为未覆盖</a:t>
+              <a:t>认证先行，准入其次，作业置后</a:t>
             </a:r>
             <a:endParaRPr lang="zh-CN" sz="1125">
               <a:solidFill>
@@ -5093,7 +5003,7 @@
                 <a:latin typeface="PingFang SC"/>
                 <a:ea typeface="PingFang SC"/>
               </a:rPr>
-              <a:t>未覆盖</a:t>
+              <a:t>认证对照</a:t>
             </a:r>
             <a:endParaRPr lang="zh-CN" sz="1050">
               <a:solidFill>
@@ -5161,7 +5071,7 @@
                 <a:latin typeface="PingFang SC"/>
                 <a:ea typeface="PingFang SC"/>
               </a:rPr>
-              <a:t>不取文首</a:t>
+              <a:t>准入其次</a:t>
             </a:r>
             <a:endParaRPr lang="zh-CN" sz="1050">
               <a:solidFill>
@@ -5229,7 +5139,7 @@
                 <a:latin typeface="PingFang SC"/>
                 <a:ea typeface="PingFang SC"/>
               </a:rPr>
-              <a:t>不造依据</a:t>
+              <a:t>作业靠后</a:t>
             </a:r>
             <a:endParaRPr lang="zh-CN" sz="1050">
               <a:solidFill>
@@ -5307,7 +5217,7 @@
                 <a:latin typeface="PingFang SC"/>
                 <a:ea typeface="PingFang SC"/>
               </a:rPr>
-              <a:t>人工复核</a:t>
+              <a:t>分步开展</a:t>
             </a:r>
             <a:endParaRPr lang="zh-CN" sz="900">
               <a:solidFill>
@@ -5720,7 +5630,7 @@
                 <a:latin typeface="PingFang SC"/>
                 <a:ea typeface="PingFang SC"/>
               </a:rPr>
-              <a:t>认证侧先行，投标侧待核</a:t>
+              <a:t>新机型或新市场取证时</a:t>
             </a:r>
             <a:endParaRPr lang="zh-CN" sz="1050">
               <a:solidFill>
@@ -5906,7 +5816,7 @@
                 <a:latin typeface="PingFang SC"/>
                 <a:ea typeface="PingFang SC"/>
               </a:rPr>
-              <a:t>系统产出</a:t>
+              <a:t>任务发生</a:t>
             </a:r>
             <a:endParaRPr lang="zh-CN" sz="1800" b="1" spc="-22">
               <a:solidFill>
@@ -5949,7 +5859,7 @@
                 <a:latin typeface="Inter"/>
                 <a:ea typeface="Inter"/>
               </a:rPr>
-              <a:t>OUTPUT</a:t>
+              <a:t>WHEN</a:t>
             </a:r>
             <a:endParaRPr lang="en-US" sz="825" spc="188">
               <a:solidFill>
@@ -6019,7 +5929,7 @@
                 <a:latin typeface="PingFang SC"/>
                 <a:ea typeface="PingFang SC"/>
               </a:rPr>
-              <a:t>列出条款、证据索引与偏离草稿</a:t>
+              <a:t>新机型、新市场或换版时组织取证。</a:t>
             </a:r>
             <a:endParaRPr lang="zh-CN" sz="1200">
               <a:solidFill>
@@ -6132,7 +6042,7 @@
                 <a:latin typeface="PingFang SC"/>
                 <a:ea typeface="PingFang SC"/>
               </a:rPr>
-              <a:t>条款清单</a:t>
+              <a:t>认证规则</a:t>
             </a:r>
             <a:r>
               <a:rPr lang="en-US" sz="1125">
@@ -6152,7 +6062,7 @@
                 <a:latin typeface="PingFang SC"/>
                 <a:ea typeface="PingFang SC"/>
               </a:rPr>
-              <a:t>证据索引</a:t>
+              <a:t>测试大纲</a:t>
             </a:r>
             <a:r>
               <a:rPr lang="en-US" sz="1125">
@@ -6172,7 +6082,7 @@
                 <a:latin typeface="PingFang SC"/>
                 <a:ea typeface="PingFang SC"/>
               </a:rPr>
-              <a:t>偏离草稿</a:t>
+              <a:t>报告证书</a:t>
             </a:r>
             <a:endParaRPr lang="zh-CN" sz="1125">
               <a:solidFill>
@@ -6308,7 +6218,7 @@
                 <a:latin typeface="PingFang SC"/>
                 <a:ea typeface="PingFang SC"/>
               </a:rPr>
-              <a:t>核对后由人提交</a:t>
+              <a:t>技术岗位发起</a:t>
             </a:r>
             <a:endParaRPr lang="zh-CN" sz="1125">
               <a:solidFill>
@@ -6386,7 +6296,7 @@
                 <a:latin typeface="PingFang SC"/>
                 <a:ea typeface="PingFang SC"/>
               </a:rPr>
-              <a:t>不代报告</a:t>
+              <a:t>多平台机型</a:t>
             </a:r>
             <a:endParaRPr lang="zh-CN" sz="900">
               <a:solidFill>
@@ -6464,7 +6374,7 @@
                 <a:latin typeface="PingFang SC"/>
                 <a:ea typeface="PingFang SC"/>
               </a:rPr>
-              <a:t>不代证书</a:t>
+              <a:t>国内国际</a:t>
             </a:r>
             <a:endParaRPr lang="zh-CN" sz="900">
               <a:solidFill>
@@ -6542,7 +6452,7 @@
                 <a:latin typeface="PingFang SC"/>
                 <a:ea typeface="PingFang SC"/>
               </a:rPr>
-              <a:t>授权提交</a:t>
+              <a:t>认证先行</a:t>
             </a:r>
             <a:endParaRPr lang="zh-CN" sz="900">
               <a:solidFill>
@@ -6728,7 +6638,7 @@
                 <a:latin typeface="PingFang SC"/>
                 <a:ea typeface="PingFang SC"/>
               </a:rPr>
-              <a:t>人来确认</a:t>
+              <a:t>材料与草稿</a:t>
             </a:r>
             <a:endParaRPr lang="zh-CN" sz="1800" b="1" spc="-22">
               <a:solidFill>
@@ -6771,7 +6681,7 @@
                 <a:latin typeface="Inter"/>
                 <a:ea typeface="Inter"/>
               </a:rPr>
-              <a:t>DECIDE</a:t>
+              <a:t>DRAFT</a:t>
             </a:r>
             <a:endParaRPr lang="en-US" sz="825" spc="188">
               <a:solidFill>
@@ -6841,7 +6751,7 @@
                 <a:latin typeface="PingFang SC"/>
                 <a:ea typeface="PingFang SC"/>
               </a:rPr>
-              <a:t>技术、商务、法务确认偏离与证据</a:t>
+              <a:t>进规则与报告；出清单、索引与偏离草稿。</a:t>
             </a:r>
             <a:endParaRPr lang="zh-CN" sz="1200">
               <a:solidFill>
@@ -6954,7 +6864,7 @@
                 <a:latin typeface="PingFang SC"/>
                 <a:ea typeface="PingFang SC"/>
               </a:rPr>
-              <a:t>技术确认</a:t>
+              <a:t>条款清单</a:t>
             </a:r>
             <a:endParaRPr lang="zh-CN" sz="1125">
               <a:solidFill>
@@ -7022,7 +6932,7 @@
                 <a:latin typeface="PingFang SC"/>
                 <a:ea typeface="PingFang SC"/>
               </a:rPr>
-              <a:t>商务确认</a:t>
+              <a:t>证据索引</a:t>
             </a:r>
             <a:endParaRPr lang="zh-CN" sz="1125">
               <a:solidFill>
@@ -7090,7 +7000,7 @@
                 <a:latin typeface="PingFang SC"/>
                 <a:ea typeface="PingFang SC"/>
               </a:rPr>
-              <a:t>法务确认</a:t>
+              <a:t>偏离草稿</a:t>
             </a:r>
             <a:endParaRPr lang="zh-CN" sz="1125">
               <a:solidFill>
@@ -7168,7 +7078,7 @@
                 <a:latin typeface="PingFang SC"/>
                 <a:ea typeface="PingFang SC"/>
               </a:rPr>
-              <a:t>偏离</a:t>
+              <a:t>未覆盖标出</a:t>
             </a:r>
             <a:endParaRPr lang="zh-CN" sz="900">
               <a:solidFill>
@@ -7246,7 +7156,7 @@
                 <a:latin typeface="PingFang SC"/>
                 <a:ea typeface="PingFang SC"/>
               </a:rPr>
-              <a:t>证据</a:t>
+              <a:t>不编造证据</a:t>
             </a:r>
             <a:endParaRPr lang="zh-CN" sz="900">
               <a:solidFill>
@@ -7324,7 +7234,7 @@
                 <a:latin typeface="PingFang SC"/>
                 <a:ea typeface="PingFang SC"/>
               </a:rPr>
-              <a:t>人来提交</a:t>
+              <a:t>不代证书</a:t>
             </a:r>
             <a:endParaRPr lang="zh-CN" sz="900">
               <a:solidFill>
@@ -7510,7 +7420,7 @@
                 <a:latin typeface="PingFang SC"/>
                 <a:ea typeface="PingFang SC"/>
               </a:rPr>
-              <a:t>留在人工</a:t>
+              <a:t>人来决定</a:t>
             </a:r>
             <a:endParaRPr lang="zh-CN" sz="1800" b="1" spc="-22">
               <a:solidFill>
@@ -7553,7 +7463,7 @@
                 <a:latin typeface="Inter"/>
                 <a:ea typeface="Inter"/>
               </a:rPr>
-              <a:t>STOP</a:t>
+              <a:t>DECIDE</a:t>
             </a:r>
             <a:endParaRPr lang="en-US" sz="825" spc="188">
               <a:solidFill>
@@ -7623,7 +7533,7 @@
                 <a:latin typeface="PingFang SC"/>
                 <a:ea typeface="PingFang SC"/>
               </a:rPr>
-              <a:t>签字、盖章与对外提交由授权人完成。</a:t>
+              <a:t>三岗确认后，授权人签署并提交。</a:t>
             </a:r>
             <a:endParaRPr lang="zh-CN" sz="1200">
               <a:solidFill>
@@ -7736,7 +7646,7 @@
                 <a:latin typeface="PingFang SC"/>
                 <a:ea typeface="PingFang SC"/>
               </a:rPr>
-              <a:t>不替代签署</a:t>
+              <a:t>技术确认</a:t>
             </a:r>
             <a:endParaRPr lang="zh-CN" sz="1125">
               <a:solidFill>
@@ -7804,7 +7714,7 @@
                 <a:latin typeface="PingFang SC"/>
                 <a:ea typeface="PingFang SC"/>
               </a:rPr>
-              <a:t>不替代盖章</a:t>
+              <a:t>商务确认</a:t>
             </a:r>
             <a:endParaRPr lang="zh-CN" sz="1125">
               <a:solidFill>
@@ -7872,7 +7782,7 @@
                 <a:latin typeface="PingFang SC"/>
                 <a:ea typeface="PingFang SC"/>
               </a:rPr>
-              <a:t>不写回系统</a:t>
+              <a:t>法务确认</a:t>
             </a:r>
             <a:endParaRPr lang="zh-CN" sz="1125">
               <a:solidFill>
@@ -7950,7 +7860,7 @@
                 <a:latin typeface="PingFang SC"/>
                 <a:ea typeface="PingFang SC"/>
               </a:rPr>
-              <a:t>认证提交</a:t>
+              <a:t>授权签署</a:t>
             </a:r>
             <a:endParaRPr lang="zh-CN" sz="900">
               <a:solidFill>
@@ -8028,7 +7938,7 @@
                 <a:latin typeface="PingFang SC"/>
                 <a:ea typeface="PingFang SC"/>
               </a:rPr>
-              <a:t>投标提交</a:t>
+              <a:t>不写回系统</a:t>
             </a:r>
             <a:endParaRPr lang="zh-CN" sz="900">
               <a:solidFill>
@@ -8106,7 +8016,7 @@
                 <a:latin typeface="PingFang SC"/>
                 <a:ea typeface="PingFang SC"/>
               </a:rPr>
-              <a:t>对外口径</a:t>
+              <a:t>对外提交</a:t>
             </a:r>
             <a:endParaRPr lang="zh-CN" sz="900">
               <a:solidFill>
@@ -8519,7 +8429,7 @@
                 <a:latin typeface="PingFang SC"/>
                 <a:ea typeface="PingFang SC"/>
               </a:rPr>
-              <a:t>采购与质量作准入结论</a:t>
+              <a:t>新供应商准入或品类扩展时</a:t>
             </a:r>
             <a:endParaRPr lang="zh-CN" sz="1050">
               <a:solidFill>
@@ -8705,7 +8615,7 @@
                 <a:latin typeface="PingFang SC"/>
                 <a:ea typeface="PingFang SC"/>
               </a:rPr>
-              <a:t>系统产出</a:t>
+              <a:t>任务发生</a:t>
             </a:r>
             <a:endParaRPr lang="zh-CN" sz="1800" b="1" spc="-22">
               <a:solidFill>
@@ -8748,7 +8658,7 @@
                 <a:latin typeface="Inter"/>
                 <a:ea typeface="Inter"/>
               </a:rPr>
-              <a:t>OUTPUT</a:t>
+              <a:t>WHEN</a:t>
             </a:r>
             <a:endParaRPr lang="en-US" sz="825" spc="188">
               <a:solidFill>
@@ -8818,7 +8728,7 @@
                 <a:latin typeface="PingFang SC"/>
                 <a:ea typeface="PingFang SC"/>
               </a:rPr>
-              <a:t>核验证书有效期、适用范围与条款命中。</a:t>
+              <a:t>准入、复审或品类扩展时核对证据。</a:t>
             </a:r>
             <a:endParaRPr lang="zh-CN" sz="1200">
               <a:solidFill>
@@ -8931,7 +8841,7 @@
                 <a:latin typeface="PingFang SC"/>
                 <a:ea typeface="PingFang SC"/>
               </a:rPr>
-              <a:t>有效期</a:t>
+              <a:t>资料审核</a:t>
             </a:r>
             <a:r>
               <a:rPr lang="en-US" sz="1125">
@@ -8951,7 +8861,7 @@
                 <a:latin typeface="PingFang SC"/>
                 <a:ea typeface="PingFang SC"/>
               </a:rPr>
-              <a:t>适用范围</a:t>
+              <a:t>认证评分</a:t>
             </a:r>
             <a:r>
               <a:rPr lang="en-US" sz="1125">
@@ -8971,7 +8881,7 @@
                 <a:latin typeface="PingFang SC"/>
                 <a:ea typeface="PingFang SC"/>
               </a:rPr>
-              <a:t>条款命中</a:t>
+              <a:t>试制验证</a:t>
             </a:r>
             <a:endParaRPr lang="zh-CN" sz="1125">
               <a:solidFill>
@@ -9039,7 +8949,7 @@
                 <a:latin typeface="PingFang SC"/>
                 <a:ea typeface="PingFang SC"/>
               </a:rPr>
-              <a:t>缺证标出待补</a:t>
+              <a:t>品类关联规则</a:t>
             </a:r>
             <a:endParaRPr lang="zh-CN" sz="1125">
               <a:solidFill>
@@ -9107,7 +9017,7 @@
                 <a:latin typeface="PingFang SC"/>
                 <a:ea typeface="PingFang SC"/>
               </a:rPr>
-              <a:t>结论由人作出</a:t>
+              <a:t>采购质量发起</a:t>
             </a:r>
             <a:endParaRPr lang="zh-CN" sz="1125">
               <a:solidFill>
@@ -9185,7 +9095,7 @@
                 <a:latin typeface="PingFang SC"/>
                 <a:ea typeface="PingFang SC"/>
               </a:rPr>
-              <a:t>不自动过</a:t>
+              <a:t>不自动通过</a:t>
             </a:r>
             <a:endParaRPr lang="zh-CN" sz="900">
               <a:solidFill>
@@ -9341,7 +9251,7 @@
                 <a:latin typeface="PingFang SC"/>
                 <a:ea typeface="PingFang SC"/>
               </a:rPr>
-              <a:t>人来判定</a:t>
+              <a:t>人作结论</a:t>
             </a:r>
             <a:endParaRPr lang="zh-CN" sz="900">
               <a:solidFill>
@@ -9527,7 +9437,7 @@
                 <a:latin typeface="PingFang SC"/>
                 <a:ea typeface="PingFang SC"/>
               </a:rPr>
-              <a:t>人来确认</a:t>
+              <a:t>材料与草稿</a:t>
             </a:r>
             <a:endParaRPr lang="zh-CN" sz="1800" b="1" spc="-22">
               <a:solidFill>
@@ -9570,7 +9480,7 @@
                 <a:latin typeface="Inter"/>
                 <a:ea typeface="Inter"/>
               </a:rPr>
-              <a:t>DECIDE</a:t>
+              <a:t>DRAFT</a:t>
             </a:r>
             <a:endParaRPr lang="en-US" sz="825" spc="188">
               <a:solidFill>
@@ -9640,7 +9550,7 @@
                 <a:latin typeface="PingFang SC"/>
                 <a:ea typeface="PingFang SC"/>
               </a:rPr>
-              <a:t>采购与质量确认证据是否支持准入。</a:t>
+              <a:t>进证书与准则；出有效期、命中与待补。</a:t>
             </a:r>
             <a:endParaRPr lang="zh-CN" sz="1200">
               <a:solidFill>
@@ -9753,7 +9663,7 @@
                 <a:latin typeface="PingFang SC"/>
                 <a:ea typeface="PingFang SC"/>
               </a:rPr>
-              <a:t>采购确认</a:t>
+              <a:t>有效期</a:t>
             </a:r>
             <a:endParaRPr lang="zh-CN" sz="1125">
               <a:solidFill>
@@ -9821,7 +9731,7 @@
                 <a:latin typeface="PingFang SC"/>
                 <a:ea typeface="PingFang SC"/>
               </a:rPr>
-              <a:t>质量确认</a:t>
+              <a:t>适用范围</a:t>
             </a:r>
             <a:endParaRPr lang="zh-CN" sz="1125">
               <a:solidFill>
@@ -9889,7 +9799,7 @@
                 <a:latin typeface="PingFang SC"/>
                 <a:ea typeface="PingFang SC"/>
               </a:rPr>
-              <a:t>证据是否够</a:t>
+              <a:t>条款命中</a:t>
             </a:r>
             <a:endParaRPr lang="zh-CN" sz="1125">
               <a:solidFill>
@@ -9967,7 +9877,7 @@
                 <a:latin typeface="PingFang SC"/>
                 <a:ea typeface="PingFang SC"/>
               </a:rPr>
-              <a:t>准入</a:t>
+              <a:t>缺证待补</a:t>
             </a:r>
             <a:endParaRPr lang="zh-CN" sz="900">
               <a:solidFill>
@@ -10045,7 +9955,7 @@
                 <a:latin typeface="PingFang SC"/>
                 <a:ea typeface="PingFang SC"/>
               </a:rPr>
-              <a:t>观察</a:t>
+              <a:t>过期标出</a:t>
             </a:r>
             <a:endParaRPr lang="zh-CN" sz="900">
               <a:solidFill>
@@ -10123,7 +10033,7 @@
                 <a:latin typeface="PingFang SC"/>
                 <a:ea typeface="PingFang SC"/>
               </a:rPr>
-              <a:t>人作结论</a:t>
+              <a:t>范围不符</a:t>
             </a:r>
             <a:endParaRPr lang="zh-CN" sz="900">
               <a:solidFill>
@@ -10309,7 +10219,7 @@
                 <a:latin typeface="PingFang SC"/>
                 <a:ea typeface="PingFang SC"/>
               </a:rPr>
-              <a:t>留在人工</a:t>
+              <a:t>人来决定</a:t>
             </a:r>
             <a:endParaRPr lang="zh-CN" sz="1800" b="1" spc="-22">
               <a:solidFill>
@@ -10352,7 +10262,7 @@
                 <a:latin typeface="Inter"/>
                 <a:ea typeface="Inter"/>
               </a:rPr>
-              <a:t>STOP</a:t>
+              <a:t>DECIDE</a:t>
             </a:r>
             <a:endParaRPr lang="en-US" sz="825" spc="188">
               <a:solidFill>
@@ -10422,7 +10332,7 @@
                 <a:latin typeface="PingFang SC"/>
                 <a:ea typeface="PingFang SC"/>
               </a:rPr>
-              <a:t>准入结论、合同条款与评分由人确定。</a:t>
+              <a:t>采购与质量确认后作出准入结论。</a:t>
             </a:r>
             <a:endParaRPr lang="zh-CN" sz="1200">
               <a:solidFill>
@@ -10535,7 +10445,7 @@
                 <a:latin typeface="PingFang SC"/>
                 <a:ea typeface="PingFang SC"/>
               </a:rPr>
-              <a:t>不替代准入</a:t>
+              <a:t>采购确认</a:t>
             </a:r>
             <a:endParaRPr lang="zh-CN" sz="1125">
               <a:solidFill>
@@ -10603,7 +10513,7 @@
                 <a:latin typeface="PingFang SC"/>
                 <a:ea typeface="PingFang SC"/>
               </a:rPr>
-              <a:t>不改合同</a:t>
+              <a:t>质量确认</a:t>
             </a:r>
             <a:endParaRPr lang="zh-CN" sz="1125">
               <a:solidFill>
@@ -10671,7 +10581,7 @@
                 <a:latin typeface="PingFang SC"/>
                 <a:ea typeface="PingFang SC"/>
               </a:rPr>
-              <a:t>不自动评分</a:t>
+              <a:t>观察补件</a:t>
             </a:r>
             <a:endParaRPr lang="zh-CN" sz="1125">
               <a:solidFill>
@@ -10749,7 +10659,7 @@
                 <a:latin typeface="PingFang SC"/>
                 <a:ea typeface="PingFang SC"/>
               </a:rPr>
-              <a:t>品类规则</a:t>
+              <a:t>通过不通过</a:t>
             </a:r>
             <a:endParaRPr lang="zh-CN" sz="900">
               <a:solidFill>
@@ -10827,7 +10737,7 @@
                 <a:latin typeface="PingFang SC"/>
                 <a:ea typeface="PingFang SC"/>
               </a:rPr>
-              <a:t>审核记录</a:t>
+              <a:t>不自动评分</a:t>
             </a:r>
             <a:endParaRPr lang="zh-CN" sz="900">
               <a:solidFill>
@@ -10905,7 +10815,7 @@
                 <a:latin typeface="PingFang SC"/>
                 <a:ea typeface="PingFang SC"/>
               </a:rPr>
-              <a:t>评价规范</a:t>
+              <a:t>结论在人</a:t>
             </a:r>
             <a:endParaRPr lang="zh-CN" sz="900">
               <a:solidFill>
@@ -11318,7 +11228,7 @@
                 <a:latin typeface="PingFang SC"/>
                 <a:ea typeface="PingFang SC"/>
               </a:rPr>
-              <a:t>换版后出影响清单与草稿</a:t>
+              <a:t>标准换版后同步作业载体</a:t>
             </a:r>
             <a:endParaRPr lang="zh-CN" sz="1050">
               <a:solidFill>
@@ -11504,7 +11414,7 @@
                 <a:latin typeface="PingFang SC"/>
                 <a:ea typeface="PingFang SC"/>
               </a:rPr>
-              <a:t>系统产出</a:t>
+              <a:t>任务发生</a:t>
             </a:r>
             <a:endParaRPr lang="zh-CN" sz="1800" b="1" spc="-22">
               <a:solidFill>
@@ -11547,7 +11457,7 @@
                 <a:latin typeface="Inter"/>
                 <a:ea typeface="Inter"/>
               </a:rPr>
-              <a:t>OUTPUT</a:t>
+              <a:t>WHEN</a:t>
             </a:r>
             <a:endParaRPr lang="en-US" sz="825" spc="188">
               <a:solidFill>
@@ -11617,7 +11527,7 @@
                 <a:latin typeface="PingFang SC"/>
                 <a:ea typeface="PingFang SC"/>
               </a:rPr>
-              <a:t>换版后列出受影响的手册、巡检项与课程，并出修订草稿。</a:t>
+              <a:t>换版或新增后排查手册、巡检与课程。</a:t>
             </a:r>
             <a:endParaRPr lang="zh-CN" sz="1200">
               <a:solidFill>
@@ -11730,7 +11640,7 @@
                 <a:latin typeface="PingFang SC"/>
                 <a:ea typeface="PingFang SC"/>
               </a:rPr>
-              <a:t>影响清单</a:t>
+              <a:t>换版通知</a:t>
             </a:r>
             <a:r>
               <a:rPr lang="en-US" sz="1125">
@@ -11750,7 +11660,7 @@
                 <a:latin typeface="PingFang SC"/>
                 <a:ea typeface="PingFang SC"/>
               </a:rPr>
-              <a:t>修订草稿</a:t>
+              <a:t>现行手册</a:t>
             </a:r>
             <a:r>
               <a:rPr lang="en-US" sz="1125">
@@ -11770,7 +11680,7 @@
                 <a:latin typeface="PingFang SC"/>
                 <a:ea typeface="PingFang SC"/>
               </a:rPr>
-              <a:t>版本对应</a:t>
+              <a:t>巡检课程</a:t>
             </a:r>
             <a:endParaRPr lang="zh-CN" sz="1125">
               <a:solidFill>
@@ -11906,7 +11816,7 @@
                 <a:latin typeface="PingFang SC"/>
                 <a:ea typeface="PingFang SC"/>
               </a:rPr>
-              <a:t>发布走原流程</a:t>
+              <a:t>工程运维发起</a:t>
             </a:r>
             <a:endParaRPr lang="zh-CN" sz="1125">
               <a:solidFill>
@@ -11984,7 +11894,7 @@
                 <a:latin typeface="PingFang SC"/>
                 <a:ea typeface="PingFang SC"/>
               </a:rPr>
-              <a:t>不改手册</a:t>
+              <a:t>试点置后</a:t>
             </a:r>
             <a:endParaRPr lang="zh-CN" sz="900">
               <a:solidFill>
@@ -12062,7 +11972,7 @@
                 <a:latin typeface="PingFang SC"/>
                 <a:ea typeface="PingFang SC"/>
               </a:rPr>
-              <a:t>不改课程</a:t>
+              <a:t>不改发布流</a:t>
             </a:r>
             <a:endParaRPr lang="zh-CN" sz="900">
               <a:solidFill>
@@ -12140,7 +12050,7 @@
                 <a:latin typeface="PingFang SC"/>
                 <a:ea typeface="PingFang SC"/>
               </a:rPr>
-              <a:t>不改巡检</a:t>
+              <a:t>公开证据弱</a:t>
             </a:r>
             <a:endParaRPr lang="zh-CN" sz="900">
               <a:solidFill>
@@ -12326,7 +12236,7 @@
                 <a:latin typeface="PingFang SC"/>
                 <a:ea typeface="PingFang SC"/>
               </a:rPr>
-              <a:t>人来确认</a:t>
+              <a:t>材料与草稿</a:t>
             </a:r>
             <a:endParaRPr lang="zh-CN" sz="1800" b="1" spc="-22">
               <a:solidFill>
@@ -12369,7 +12279,7 @@
                 <a:latin typeface="Inter"/>
                 <a:ea typeface="Inter"/>
               </a:rPr>
-              <a:t>DECIDE</a:t>
+              <a:t>DRAFT</a:t>
             </a:r>
             <a:endParaRPr lang="en-US" sz="825" spc="188">
               <a:solidFill>
@@ -12439,7 +12349,7 @@
                 <a:latin typeface="PingFang SC"/>
                 <a:ea typeface="PingFang SC"/>
               </a:rPr>
-              <a:t>工程与运维负责人确认影响范围并签核。</a:t>
+              <a:t>出影响清单与修订草稿，清单仅为候选。</a:t>
             </a:r>
             <a:endParaRPr lang="zh-CN" sz="1200">
               <a:solidFill>
@@ -12552,7 +12462,7 @@
                 <a:latin typeface="PingFang SC"/>
                 <a:ea typeface="PingFang SC"/>
               </a:rPr>
-              <a:t>工程确认</a:t>
+              <a:t>影响清单</a:t>
             </a:r>
             <a:endParaRPr lang="zh-CN" sz="1125">
               <a:solidFill>
@@ -12620,7 +12530,7 @@
                 <a:latin typeface="PingFang SC"/>
                 <a:ea typeface="PingFang SC"/>
               </a:rPr>
-              <a:t>运维确认</a:t>
+              <a:t>修订草稿</a:t>
             </a:r>
             <a:endParaRPr lang="zh-CN" sz="1125">
               <a:solidFill>
@@ -12688,7 +12598,7 @@
                 <a:latin typeface="PingFang SC"/>
                 <a:ea typeface="PingFang SC"/>
               </a:rPr>
-              <a:t>培训确认</a:t>
+              <a:t>版本对应</a:t>
             </a:r>
             <a:endParaRPr lang="zh-CN" sz="1125">
               <a:solidFill>
@@ -12766,7 +12676,7 @@
                 <a:latin typeface="PingFang SC"/>
                 <a:ea typeface="PingFang SC"/>
               </a:rPr>
-              <a:t>影响范围</a:t>
+              <a:t>漏改标出</a:t>
             </a:r>
             <a:endParaRPr lang="zh-CN" sz="900">
               <a:solidFill>
@@ -12844,7 +12754,7 @@
                 <a:latin typeface="PingFang SC"/>
                 <a:ea typeface="PingFang SC"/>
               </a:rPr>
-              <a:t>修订稿</a:t>
+              <a:t>不自动下发</a:t>
             </a:r>
             <a:endParaRPr lang="zh-CN" sz="900">
               <a:solidFill>
@@ -12922,7 +12832,7 @@
                 <a:latin typeface="PingFang SC"/>
                 <a:ea typeface="PingFang SC"/>
               </a:rPr>
-              <a:t>签核后发</a:t>
+              <a:t>不改手册</a:t>
             </a:r>
             <a:endParaRPr lang="zh-CN" sz="900">
               <a:solidFill>
@@ -13108,7 +13018,7 @@
                 <a:latin typeface="PingFang SC"/>
                 <a:ea typeface="PingFang SC"/>
               </a:rPr>
-              <a:t>留在人工</a:t>
+              <a:t>人来决定</a:t>
             </a:r>
             <a:endParaRPr lang="zh-CN" sz="1800" b="1" spc="-22">
               <a:solidFill>
@@ -13151,7 +13061,7 @@
                 <a:latin typeface="Inter"/>
                 <a:ea typeface="Inter"/>
               </a:rPr>
-              <a:t>STOP</a:t>
+              <a:t>DECIDE</a:t>
             </a:r>
             <a:endParaRPr lang="en-US" sz="825" spc="188">
               <a:solidFill>
@@ -13221,7 +13131,7 @@
                 <a:latin typeface="PingFang SC"/>
                 <a:ea typeface="PingFang SC"/>
               </a:rPr>
-              <a:t>手册、课程与巡检的发布仍走现有流程。</a:t>
+              <a:t>三方签核后，仍走原手册与培训发布。</a:t>
             </a:r>
             <a:endParaRPr lang="zh-CN" sz="1200">
               <a:solidFill>
@@ -13334,7 +13244,7 @@
                 <a:latin typeface="PingFang SC"/>
                 <a:ea typeface="PingFang SC"/>
               </a:rPr>
-              <a:t>不改发布流</a:t>
+              <a:t>工程确认</a:t>
             </a:r>
             <a:endParaRPr lang="zh-CN" sz="1125">
               <a:solidFill>
@@ -13402,7 +13312,7 @@
                 <a:latin typeface="PingFang SC"/>
                 <a:ea typeface="PingFang SC"/>
               </a:rPr>
-              <a:t>不自动下发</a:t>
+              <a:t>运维确认</a:t>
             </a:r>
             <a:endParaRPr lang="zh-CN" sz="1125">
               <a:solidFill>
@@ -13470,7 +13380,7 @@
                 <a:latin typeface="PingFang SC"/>
                 <a:ea typeface="PingFang SC"/>
               </a:rPr>
-              <a:t>不替代签核</a:t>
+              <a:t>培训确认</a:t>
             </a:r>
             <a:endParaRPr lang="zh-CN" sz="1125">
               <a:solidFill>
@@ -13548,7 +13458,7 @@
                 <a:latin typeface="PingFang SC"/>
                 <a:ea typeface="PingFang SC"/>
               </a:rPr>
-              <a:t>技术手册</a:t>
+              <a:t>签核后发</a:t>
             </a:r>
             <a:endParaRPr lang="zh-CN" sz="900">
               <a:solidFill>
@@ -13626,7 +13536,7 @@
                 <a:latin typeface="PingFang SC"/>
                 <a:ea typeface="PingFang SC"/>
               </a:rPr>
-              <a:t>巡检项</a:t>
+              <a:t>原流程发布</a:t>
             </a:r>
             <a:endParaRPr lang="zh-CN" sz="900">
               <a:solidFill>
@@ -13704,7 +13614,7 @@
                 <a:latin typeface="PingFang SC"/>
                 <a:ea typeface="PingFang SC"/>
               </a:rPr>
-              <a:t>培训课程</a:t>
+              <a:t>许可在人</a:t>
             </a:r>
             <a:endParaRPr lang="zh-CN" sz="900">
               <a:solidFill>
@@ -14006,7 +13916,7 @@
                 <a:latin typeface="PingFang SC"/>
                 <a:ea typeface="PingFang SC"/>
               </a:rPr>
-              <a:t>共用底座</a:t>
+              <a:t>场景前提</a:t>
             </a:r>
             <a:endParaRPr lang="zh-CN" sz="2400" b="1" spc="-37">
               <a:solidFill>
@@ -14117,7 +14027,7 @@
                 <a:latin typeface="PingFang SC"/>
                 <a:ea typeface="PingFang SC"/>
               </a:rPr>
-              <a:t>已有则接入，否则做最小集</a:t>
+              <a:t>已有则接入，服务三个场景</a:t>
             </a:r>
             <a:endParaRPr lang="zh-CN" sz="1050">
               <a:solidFill>
@@ -14358,7 +14268,7 @@
                 <a:latin typeface="PingFang SC"/>
                 <a:ea typeface="PingFang SC"/>
               </a:rPr>
-              <a:t>每条可引用内容写明标准号、条款号、版本与适用范围。</a:t>
+              <a:t>引用须写明标准号、条款号、版本与适用范围。</a:t>
             </a:r>
             <a:endParaRPr lang="zh-CN" sz="1200">
               <a:solidFill>
@@ -14444,7 +14354,7 @@
                 <a:latin typeface="PingFang SC"/>
                 <a:ea typeface="PingFang SC"/>
               </a:rPr>
-              <a:t>四项必填</a:t>
+              <a:t>缺一不引用</a:t>
             </a:r>
             <a:endParaRPr lang="zh-CN" sz="1050">
               <a:solidFill>
@@ -14685,7 +14595,7 @@
                 <a:latin typeface="PingFang SC"/>
                 <a:ea typeface="PingFang SC"/>
               </a:rPr>
-              <a:t>标准、机型与市场的对应。没有这张表，认证应答无法定位条款。</a:t>
+              <a:t>认证应答按机型与市场定位条款。已有则接入。</a:t>
             </a:r>
             <a:endParaRPr lang="zh-CN" sz="1200">
               <a:solidFill>
@@ -14771,7 +14681,7 @@
                 <a:latin typeface="PingFang SC"/>
                 <a:ea typeface="PingFang SC"/>
               </a:rPr>
-              <a:t>先核后接</a:t>
+              <a:t>定位条款</a:t>
             </a:r>
             <a:endParaRPr lang="zh-CN" sz="1050">
               <a:solidFill>
@@ -15012,7 +14922,7 @@
                 <a:latin typeface="PingFang SC"/>
                 <a:ea typeface="PingFang SC"/>
               </a:rPr>
-              <a:t>标准到手册、合同、巡检项、课程的对应。作业同步依赖这张表。</a:t>
+              <a:t>作业同步依赖标准到手册、巡检与课程的对应。</a:t>
             </a:r>
             <a:endParaRPr lang="zh-CN" sz="1200">
               <a:solidFill>
@@ -15339,7 +15249,7 @@
                 <a:latin typeface="PingFang SC"/>
                 <a:ea typeface="PingFang SC"/>
               </a:rPr>
-              <a:t>新版本发布并退役旧版本。旧版本留档，不再被新任务引用。</a:t>
+              <a:t>新版本发布后旧版退役留档，新任务不再引用。</a:t>
             </a:r>
             <a:endParaRPr lang="zh-CN" sz="1200">
               <a:solidFill>
@@ -15766,7 +15676,7 @@
                 <a:latin typeface="PingFang SC"/>
                 <a:ea typeface="PingFang SC"/>
               </a:rPr>
-              <a:t>落地顺序</a:t>
+              <a:t>场景次序</a:t>
             </a:r>
             <a:endParaRPr lang="zh-CN" sz="2400" b="1" spc="-37">
               <a:solidFill>
@@ -15877,7 +15787,7 @@
                 <a:latin typeface="PingFang SC"/>
                 <a:ea typeface="PingFang SC"/>
               </a:rPr>
-              <a:t>先核实现状，再做对照</a:t>
+              <a:t>先对照哪个场景</a:t>
             </a:r>
             <a:endParaRPr lang="zh-CN" sz="1050">
               <a:solidFill>
@@ -16045,7 +15955,7 @@
                 <a:latin typeface="PingFang SC"/>
                 <a:ea typeface="PingFang SC"/>
               </a:rPr>
-              <a:t>先核系统</a:t>
+              <a:t>核现有库</a:t>
             </a:r>
             <a:endParaRPr lang="zh-CN" sz="1500" b="1" spc="-22">
               <a:solidFill>
@@ -16115,7 +16025,7 @@
                 <a:latin typeface="PingFang SC"/>
                 <a:ea typeface="PingFang SC"/>
               </a:rPr>
-              <a:t>已有则接入，没有则做最小集</a:t>
+              <a:t>已有系统则接入后再对照</a:t>
             </a:r>
             <a:endParaRPr lang="zh-CN" sz="1125">
               <a:solidFill>
@@ -16595,7 +16505,7 @@
                 <a:latin typeface="PingFang SC"/>
                 <a:ea typeface="PingFang SC"/>
               </a:rPr>
-              <a:t>核三张表</a:t>
+              <a:t>认证对照</a:t>
             </a:r>
             <a:endParaRPr lang="zh-CN" sz="1500" b="1" spc="-22">
               <a:solidFill>
@@ -16665,7 +16575,7 @@
                 <a:latin typeface="PingFang SC"/>
                 <a:ea typeface="PingFang SC"/>
               </a:rPr>
-              <a:t>机型、载体与版本</a:t>
+              <a:t>选定认证包，出清单与偏离草稿</a:t>
             </a:r>
             <a:endParaRPr lang="zh-CN" sz="1125">
               <a:solidFill>
@@ -16733,7 +16643,7 @@
                 <a:latin typeface="PingFang SC"/>
                 <a:ea typeface="PingFang SC"/>
               </a:rPr>
-              <a:t>机型市场</a:t>
+              <a:t>条款清单</a:t>
             </a:r>
             <a:endParaRPr lang="zh-CN" sz="1050">
               <a:solidFill>
@@ -16801,7 +16711,7 @@
                 <a:latin typeface="PingFang SC"/>
                 <a:ea typeface="PingFang SC"/>
               </a:rPr>
-              <a:t>载体对应</a:t>
+              <a:t>证据索引</a:t>
             </a:r>
             <a:endParaRPr lang="zh-CN" sz="1050">
               <a:solidFill>
@@ -16869,7 +16779,7 @@
                 <a:latin typeface="PingFang SC"/>
                 <a:ea typeface="PingFang SC"/>
               </a:rPr>
-              <a:t>版本替代</a:t>
+              <a:t>偏离草稿</a:t>
             </a:r>
             <a:endParaRPr lang="zh-CN" sz="1050">
               <a:solidFill>
@@ -16947,7 +16857,7 @@
                 <a:latin typeface="PingFang SC"/>
                 <a:ea typeface="PingFang SC"/>
               </a:rPr>
-              <a:t>缺表先补</a:t>
+              <a:t>提交由人</a:t>
             </a:r>
             <a:endParaRPr lang="zh-CN" sz="900">
               <a:solidFill>
@@ -17145,7 +17055,7 @@
                 <a:latin typeface="PingFang SC"/>
                 <a:ea typeface="PingFang SC"/>
               </a:rPr>
-              <a:t>核两条线</a:t>
+              <a:t>准入其次</a:t>
             </a:r>
             <a:endParaRPr lang="zh-CN" sz="1500" b="1" spc="-22">
               <a:solidFill>
@@ -17215,7 +17125,7 @@
                 <a:latin typeface="PingFang SC"/>
                 <a:ea typeface="PingFang SC"/>
               </a:rPr>
-              <a:t>投标编制与准入基线</a:t>
+              <a:t>先做证据包，结论仍由人作出</a:t>
             </a:r>
             <a:endParaRPr lang="zh-CN" sz="1125">
               <a:solidFill>
@@ -17283,7 +17193,7 @@
                 <a:latin typeface="PingFang SC"/>
                 <a:ea typeface="PingFang SC"/>
               </a:rPr>
-              <a:t>投标编制</a:t>
+              <a:t>有效期</a:t>
             </a:r>
             <a:endParaRPr lang="zh-CN" sz="1050">
               <a:solidFill>
@@ -17351,7 +17261,7 @@
                 <a:latin typeface="PingFang SC"/>
                 <a:ea typeface="PingFang SC"/>
               </a:rPr>
-              <a:t>准入基线</a:t>
+              <a:t>范围命中</a:t>
             </a:r>
             <a:endParaRPr lang="zh-CN" sz="1050">
               <a:solidFill>
@@ -17419,7 +17329,7 @@
                 <a:latin typeface="PingFang SC"/>
                 <a:ea typeface="PingFang SC"/>
               </a:rPr>
-              <a:t>确认角色</a:t>
+              <a:t>待补标出</a:t>
             </a:r>
             <a:endParaRPr lang="zh-CN" sz="1050">
               <a:solidFill>
@@ -17497,7 +17407,7 @@
                 <a:latin typeface="PingFang SC"/>
                 <a:ea typeface="PingFang SC"/>
               </a:rPr>
-              <a:t>访谈核验</a:t>
+              <a:t>结论在人</a:t>
             </a:r>
             <a:endParaRPr lang="zh-CN" sz="900">
               <a:solidFill>
@@ -17695,7 +17605,7 @@
                 <a:latin typeface="PingFang SC"/>
                 <a:ea typeface="PingFang SC"/>
               </a:rPr>
-              <a:t>对照运行</a:t>
+              <a:t>作业置后</a:t>
             </a:r>
             <a:endParaRPr lang="zh-CN" sz="1500" b="1" spc="-22">
               <a:solidFill>
@@ -17765,7 +17675,7 @@
                 <a:latin typeface="PingFang SC"/>
                 <a:ea typeface="PingFang SC"/>
               </a:rPr>
-              <a:t>先对照，提交由人</a:t>
+              <a:t>对应核清后再做影响清单</a:t>
             </a:r>
             <a:endParaRPr lang="zh-CN" sz="1125">
               <a:solidFill>
@@ -17833,7 +17743,7 @@
                 <a:latin typeface="PingFang SC"/>
                 <a:ea typeface="PingFang SC"/>
               </a:rPr>
-              <a:t>条款清单</a:t>
+              <a:t>影响清单</a:t>
             </a:r>
             <a:endParaRPr lang="zh-CN" sz="1050">
               <a:solidFill>
@@ -17901,7 +17811,7 @@
                 <a:latin typeface="PingFang SC"/>
                 <a:ea typeface="PingFang SC"/>
               </a:rPr>
-              <a:t>证据索引</a:t>
+              <a:t>修订草稿</a:t>
             </a:r>
             <a:endParaRPr lang="zh-CN" sz="1050">
               <a:solidFill>
@@ -17969,7 +17879,7 @@
                 <a:latin typeface="PingFang SC"/>
                 <a:ea typeface="PingFang SC"/>
               </a:rPr>
-              <a:t>偏离草稿</a:t>
+              <a:t>原流程发</a:t>
             </a:r>
             <a:endParaRPr lang="zh-CN" sz="1050">
               <a:solidFill>
@@ -18047,7 +17957,7 @@
                 <a:latin typeface="PingFang SC"/>
                 <a:ea typeface="PingFang SC"/>
               </a:rPr>
-              <a:t>人来提交</a:t>
+              <a:t>证据较弱</a:t>
             </a:r>
             <a:endParaRPr lang="zh-CN" sz="900">
               <a:solidFill>
@@ -18245,7 +18155,7 @@
                 <a:latin typeface="PingFang SC"/>
                 <a:ea typeface="PingFang SC"/>
               </a:rPr>
-              <a:t>先后次序</a:t>
+              <a:t>验收口径</a:t>
             </a:r>
             <a:endParaRPr lang="zh-CN" sz="1500" b="1" spc="-22">
               <a:solidFill>
@@ -18315,7 +18225,7 @@
                 <a:latin typeface="PingFang SC"/>
                 <a:ea typeface="PingFang SC"/>
               </a:rPr>
-              <a:t>准入其次，同步置后</a:t>
+              <a:t>引用可回链，未命中即未覆盖</a:t>
             </a:r>
             <a:endParaRPr lang="zh-CN" sz="1125">
               <a:solidFill>
@@ -18383,7 +18293,7 @@
                 <a:latin typeface="PingFang SC"/>
                 <a:ea typeface="PingFang SC"/>
               </a:rPr>
-              <a:t>认证先行</a:t>
+              <a:t>可回链</a:t>
             </a:r>
             <a:endParaRPr lang="zh-CN" sz="1050">
               <a:solidFill>
@@ -18451,7 +18361,7 @@
                 <a:latin typeface="PingFang SC"/>
                 <a:ea typeface="PingFang SC"/>
               </a:rPr>
-              <a:t>准入其次</a:t>
+              <a:t>未覆盖</a:t>
             </a:r>
             <a:endParaRPr lang="zh-CN" sz="1050">
               <a:solidFill>
@@ -18519,7 +18429,7 @@
                 <a:latin typeface="PingFang SC"/>
                 <a:ea typeface="PingFang SC"/>
               </a:rPr>
-              <a:t>作业靠后</a:t>
+              <a:t>不写回</a:t>
             </a:r>
             <a:endParaRPr lang="zh-CN" sz="1050">
               <a:solidFill>
@@ -18597,7 +18507,7 @@
                 <a:latin typeface="PingFang SC"/>
                 <a:ea typeface="PingFang SC"/>
               </a:rPr>
-              <a:t>分步试点</a:t>
+              <a:t>不承诺周期</a:t>
             </a:r>
             <a:endParaRPr lang="zh-CN" sz="900">
               <a:solidFill>
@@ -19010,7 +18920,7 @@
                 <a:latin typeface="PingFang SC"/>
                 <a:ea typeface="PingFang SC"/>
               </a:rPr>
-              <a:t>可做、保留与不作承诺</a:t>
+              <a:t>三个场景的草稿范围</a:t>
             </a:r>
             <a:endParaRPr lang="zh-CN" sz="1050">
               <a:solidFill>
@@ -19190,7 +19100,7 @@
                 <a:latin typeface="PingFang SC"/>
                 <a:ea typeface="PingFang SC"/>
               </a:rPr>
-              <a:t>找依据、比对与草稿</a:t>
+              <a:t>三个场景的依据与草稿</a:t>
             </a:r>
             <a:endParaRPr lang="zh-CN" sz="1200">
               <a:solidFill>
@@ -19316,7 +19226,7 @@
                 <a:latin typeface="PingFang SC"/>
                 <a:ea typeface="PingFang SC"/>
               </a:rPr>
-              <a:t>按条款检索当前有效依据</a:t>
+              <a:t>认证：条款清单与偏离草稿</a:t>
             </a:r>
             <a:endParaRPr lang="zh-CN" sz="1050">
               <a:solidFill>
@@ -19434,7 +19344,7 @@
                 <a:latin typeface="PingFang SC"/>
                 <a:ea typeface="PingFang SC"/>
               </a:rPr>
-              <a:t>比对后标出偏离</a:t>
+              <a:t>准入：证据包与待补项</a:t>
             </a:r>
             <a:endParaRPr lang="zh-CN" sz="1200">
               <a:solidFill>
@@ -19507,7 +19417,7 @@
                 <a:latin typeface="PingFang SC"/>
                 <a:ea typeface="PingFang SC"/>
               </a:rPr>
-              <a:t>输出修订草稿</a:t>
+              <a:t>作业：影响清单与修订稿</a:t>
             </a:r>
             <a:endParaRPr lang="zh-CN" sz="1200">
               <a:solidFill>
@@ -22327,7 +22237,7 @@
                 <a:latin typeface="PingFang SC"/>
                 <a:ea typeface="PingFang SC"/>
               </a:rPr>
-              <a:t>引用方式</a:t>
+              <a:t>场景总览</a:t>
             </a:r>
             <a:r>
               <a:rPr lang="en-US" sz="1200">
@@ -22584,7 +22494,7 @@
                 <a:latin typeface="PingFang SC"/>
                 <a:ea typeface="PingFang SC"/>
               </a:rPr>
-              <a:t>底座、试点顺序与实施边界</a:t>
+              <a:t>场景先后与实施边界</a:t>
             </a:r>
             <a:endParaRPr lang="zh-CN" sz="1200">
               <a:solidFill>
@@ -34860,7 +34770,7 @@
                 <a:latin typeface="PingFang SC"/>
                 <a:ea typeface="PingFang SC"/>
               </a:rPr>
-              <a:t>人工保留</a:t>
+              <a:t>决定仍在人</a:t>
             </a:r>
             <a:endParaRPr lang="zh-CN" sz="2400" b="1" spc="-37">
               <a:solidFill>
@@ -34971,7 +34881,7 @@
                 <a:latin typeface="PingFang SC"/>
                 <a:ea typeface="PingFang SC"/>
               </a:rPr>
-              <a:t>草稿与风险由系统给出</a:t>
+              <a:t>系统只到草稿与风险</a:t>
             </a:r>
             <a:endParaRPr lang="zh-CN" sz="1050">
               <a:solidFill>

</xml_diff>